<commit_message>
exec review: discount-leakage drill-down slide; rebuild deliverables
New slide 7 (waterfall gross -> within-policy -> excess -> net, top-6 reps
by excess-over-policy, top-offender callout); PDF/PPTX now 9 slides.
Deliverables regenerated with the drill-down in analysis.json, QBR
markdown, workbook and the new leakage_waterfall.png.
</commit_message>
<xml_diff>
--- a/deliverables/executive_review.pptx
+++ b/deliverables/executive_review.pptx
@@ -13,6 +13,7 @@
     <p:sldId id="261" r:id="rId12"/>
     <p:sldId id="262" r:id="rId13"/>
     <p:sldId id="263" r:id="rId14"/>
+    <p:sldId id="264" r:id="rId15"/>
   </p:sldIdLst>
   <p:sldSz cx="12188952" cy="6858000" type="screen4x3"/>
   <p:notesSz cx="6858000" cy="9144000"/>
@@ -3421,6 +3422,48 @@
 </p:sld>
 </file>
 
+<file path=ppt/slides/slide9.xml><?xml version="1.0" encoding="utf-8"?>
+<p:sld xmlns:a="http://schemas.openxmlformats.org/drawingml/2006/main" xmlns:p="http://schemas.openxmlformats.org/presentationml/2006/main" xmlns:r="http://schemas.openxmlformats.org/officeDocument/2006/relationships">
+  <p:cSld>
+    <p:spTree>
+      <p:nvGrpSpPr>
+        <p:cNvPr id="1" name=""/>
+        <p:cNvGrpSpPr/>
+        <p:nvPr/>
+      </p:nvGrpSpPr>
+      <p:grpSpPr/>
+      <p:pic>
+        <p:nvPicPr>
+          <p:cNvPr id="2" name="Picture 1" descr="slide_09.png"/>
+          <p:cNvPicPr>
+            <a:picLocks noChangeAspect="1"/>
+          </p:cNvPicPr>
+          <p:nvPr/>
+        </p:nvPicPr>
+        <p:blipFill>
+          <a:blip r:embed="rId2"/>
+          <a:stretch>
+            <a:fillRect/>
+          </a:stretch>
+        </p:blipFill>
+        <p:spPr>
+          <a:xfrm>
+            <a:off x="0" y="0"/>
+            <a:ext cx="12188952" cy="6858000"/>
+          </a:xfrm>
+          <a:prstGeom prst="rect">
+            <a:avLst/>
+          </a:prstGeom>
+        </p:spPr>
+      </p:pic>
+    </p:spTree>
+  </p:cSld>
+  <p:clrMapOvr>
+    <a:masterClrMapping/>
+  </p:clrMapOvr>
+</p:sld>
+</file>
+
 <file path=ppt/theme/theme1.xml><?xml version="1.0" encoding="utf-8"?>
 <a:theme xmlns:a="http://schemas.openxmlformats.org/drawingml/2006/main" name="Office Theme">
   <a:themeElements>

</xml_diff>